<commit_message>
feat: 덱 캡처를 실제 플랫폼 화면으로 교체 (Swagger UI·Kubernetes Dashboard·실제 CLI)
- capture_platform_screens.py: 실행 중인 Manager의 Swagger UI에서 실제 요청 실행
  (등록→X.509 발급, operator JWT, devices, RBAC 403 거부, admin 감사조회)
- capture_cli_screens.py: demo/gateway/fleet의 진짜 stdout을 실제 브라우저로 렌더
- capture_screens.py: 문서·매니페스트 대조 2종만 담당하도록 정리
- app.py: OpenAPI에 HTTPBearer 스킴 선언(auto_error=False, 인가 동작 불변)
  → Swagger UI에서 인증 필요한 API도 실제 실행·캡처 가능
- 매핑 덱 19슬라이드(실제 K8s 클러스터 화면 추가), 변화 덱 3분할 배치 지원
- 구형 합성 캡처(screen_devices/audit/swagger) 제거

Co-Authored-By: Claude Fable 5 <noreply@anthropic.com>
</commit_message>
<xml_diff>
--- a/ppt/ETRI_2차년도_기존-현재_화면구성.pptx
+++ b/ppt/ETRI_2차년도_기존-현재_화면구성.pptx
@@ -3180,7 +3180,7 @@
                 <a:latin typeface="맑은 고딕"/>
                 <a:ea typeface="맑은 고딕"/>
               </a:rPr>
-              <a:t>ETRI 2차 킥오프 매핑 자료 기준 - 기존(1차년도) → 현재(2차년도), 캡처는 실제 실행 화면</a:t>
+              <a:t>ETRI 2차 킥오프 매핑 자료 기준 - 기존(1차년도) → 현재(2차년도), 캡처는 실제 플랫폼 화면(Swagger UI·Kubernetes Dashboard·실제 CLI 출력)</a:t>
             </a:r>
           </a:p>
         </p:txBody>
@@ -3383,7 +3383,7 @@
                 <a:latin typeface="맑은 고딕"/>
                 <a:ea typeface="맑은 고딕"/>
               </a:rPr>
-              <a:t>• 보안 코어 모듈을 K8s에 탑재 - eam-manager:v2/eam-agent:v2 이미지·매니페스트·Dockerfile 포함</a:t>
+              <a:t>• 보안 코어 모듈이 실제 K8s 클러스터에서 구동 - manager/agent×2/gateway 4개 파드 Running</a:t>
             </a:r>
           </a:p>
           <a:p>
@@ -3407,7 +3407,7 @@
       </p:sp>
       <p:pic>
         <p:nvPicPr>
-          <p:cNvPr id="7" name="Picture 6" descr="p95_latency_vs_n.png"/>
+          <p:cNvPr id="7" name="Picture 6" descr="k8s_pods.png"/>
           <p:cNvPicPr>
             <a:picLocks noChangeAspect="1"/>
           </p:cNvPicPr>
@@ -3421,8 +3421,8 @@
         </p:blipFill>
         <p:spPr>
           <a:xfrm>
-            <a:off x="521208" y="2542032"/>
-            <a:ext cx="5404104" cy="3602736"/>
+            <a:off x="457200" y="2542032"/>
+            <a:ext cx="5545836" cy="2022381"/>
           </a:xfrm>
           <a:prstGeom prst="rect">
             <a:avLst/>
@@ -3437,8 +3437,8 @@
         </p:nvSpPr>
         <p:spPr>
           <a:xfrm>
-            <a:off x="457200" y="6199632"/>
-            <a:ext cx="5532120" cy="292608"/>
+            <a:off x="457200" y="5998464"/>
+            <a:ext cx="5545836" cy="566928"/>
           </a:xfrm>
           <a:prstGeom prst="rect">
             <a:avLst/>
@@ -3446,7 +3446,7 @@
           <a:noFill/>
         </p:spPr>
         <p:txBody>
-          <a:bodyPr wrap="square" anchor="t" lIns="0" rIns="0" tIns="0" bIns="0">
+          <a:bodyPr wrap="square" anchor="t">
             <a:spAutoFit/>
           </a:bodyPr>
           <a:lstStyle/>
@@ -3460,14 +3460,14 @@
                 <a:latin typeface="맑은 고딕"/>
                 <a:ea typeface="맑은 고딕"/>
               </a:rPr>
-              <a:t>실측 auth p95 지연 vs N (bench/run_bench.py 산출)</a:t>
+              <a:t>실제 클러스터 상태 - edge 라벨 노드에 agent/gateway 배치, manager NodePort 30443</a:t>
             </a:r>
           </a:p>
         </p:txBody>
       </p:sp>
       <p:pic>
         <p:nvPicPr>
-          <p:cNvPr id="9" name="Picture 8" descr="screen_fleet.png"/>
+          <p:cNvPr id="9" name="Picture 8" descr="p95_latency_vs_n.png"/>
           <p:cNvPicPr>
             <a:picLocks noChangeAspect="1"/>
           </p:cNvPicPr>
@@ -3481,8 +3481,8 @@
         </p:blipFill>
         <p:spPr>
           <a:xfrm>
-            <a:off x="6199632" y="2597792"/>
-            <a:ext cx="5532120" cy="3491216"/>
+            <a:off x="6421374" y="2542032"/>
+            <a:ext cx="5074920" cy="3383280"/>
           </a:xfrm>
           <a:prstGeom prst="rect">
             <a:avLst/>
@@ -3497,8 +3497,8 @@
         </p:nvSpPr>
         <p:spPr>
           <a:xfrm>
-            <a:off x="6199632" y="6143872"/>
-            <a:ext cx="5532120" cy="292608"/>
+            <a:off x="6185916" y="5998464"/>
+            <a:ext cx="5545836" cy="566928"/>
           </a:xfrm>
           <a:prstGeom prst="rect">
             <a:avLst/>
@@ -3506,7 +3506,7 @@
           <a:noFill/>
         </p:spPr>
         <p:txBody>
-          <a:bodyPr wrap="square" anchor="t" lIns="0" rIns="0" tIns="0" bIns="0">
+          <a:bodyPr wrap="square" anchor="t">
             <a:spAutoFit/>
           </a:bodyPr>
           <a:lstStyle/>
@@ -3520,7 +3520,7 @@
                 <a:latin typeface="맑은 고딕"/>
                 <a:ea typeface="맑은 고딕"/>
               </a:rPr>
-              <a:t>가상 디바이스 일괄 등록·인증·전송 실행 화면 (단계별 p50/p95/p99)</a:t>
+              <a:t>실측 auth p95 지연 vs N (bench/run_bench.py 산출)</a:t>
             </a:r>
           </a:p>
         </p:txBody>
@@ -3700,7 +3700,7 @@
                 <a:latin typeface="맑은 고딕"/>
                 <a:ea typeface="맑은 고딕"/>
               </a:rPr>
-              <a:t>ETRI 2차 킥오프 매핑 자료 기준 - 기존(1차년도) → 현재(2차년도), 캡처는 실제 실행 화면</a:t>
+              <a:t>ETRI 2차 킥오프 매핑 자료 기준 - 기존(1차년도) → 현재(2차년도), 캡처는 실제 플랫폼 화면(Swagger UI·Kubernetes Dashboard·실제 CLI 출력)</a:t>
             </a:r>
           </a:p>
         </p:txBody>
@@ -4160,7 +4160,7 @@
                 <a:latin typeface="맑은 고딕"/>
                 <a:ea typeface="맑은 고딕"/>
               </a:rPr>
-              <a:t>ETRI 2차 킥오프 매핑 자료 기준 - 기존(1차년도) → 현재(2차년도), 캡처는 실제 실행 화면</a:t>
+              <a:t>ETRI 2차 킥오프 매핑 자료 기준 - 기존(1차년도) → 현재(2차년도), 캡처는 실제 플랫폼 화면(Swagger UI·Kubernetes Dashboard·실제 CLI 출력)</a:t>
             </a:r>
           </a:p>
         </p:txBody>
@@ -4387,7 +4387,7 @@
       </p:sp>
       <p:pic>
         <p:nvPicPr>
-          <p:cNvPr id="7" name="Picture 6" descr="screen_devices.png"/>
+          <p:cNvPr id="7" name="Picture 6" descr="platform_register.png"/>
           <p:cNvPicPr>
             <a:picLocks noChangeAspect="1"/>
           </p:cNvPicPr>
@@ -4401,8 +4401,8 @@
         </p:blipFill>
         <p:spPr>
           <a:xfrm>
-            <a:off x="457200" y="2822067"/>
-            <a:ext cx="5532120" cy="3042666"/>
+            <a:off x="574108" y="2542032"/>
+            <a:ext cx="3402448" cy="3383280"/>
           </a:xfrm>
           <a:prstGeom prst="rect">
             <a:avLst/>
@@ -4417,8 +4417,8 @@
         </p:nvSpPr>
         <p:spPr>
           <a:xfrm>
-            <a:off x="457200" y="5919597"/>
-            <a:ext cx="5532120" cy="292608"/>
+            <a:off x="457200" y="5998464"/>
+            <a:ext cx="3636264" cy="566928"/>
           </a:xfrm>
           <a:prstGeom prst="rect">
             <a:avLst/>
@@ -4426,7 +4426,7 @@
           <a:noFill/>
         </p:spPr>
         <p:txBody>
-          <a:bodyPr wrap="square" anchor="t" lIns="0" rIns="0" tIns="0" bIns="0">
+          <a:bodyPr wrap="square" anchor="t">
             <a:spAutoFit/>
           </a:bodyPr>
           <a:lstStyle/>
@@ -4440,14 +4440,14 @@
                 <a:latin typeface="맑은 고딕"/>
                 <a:ea typeface="맑은 고딕"/>
               </a:rPr>
-              <a:t>GET /devices - 등록 상태·인증서 시리얼·last_seen (revoked 포함)</a:t>
+              <a:t>Authentication - 등록 요청에 X.509 인증서가 실제 발급된 응답</a:t>
             </a:r>
           </a:p>
         </p:txBody>
       </p:sp>
       <p:pic>
         <p:nvPicPr>
-          <p:cNvPr id="9" name="Picture 8" descr="screen_audit.png"/>
+          <p:cNvPr id="9" name="Picture 8" descr="platform_rbac_denied.png"/>
           <p:cNvPicPr>
             <a:picLocks noChangeAspect="1"/>
           </p:cNvPicPr>
@@ -4461,8 +4461,8 @@
         </p:blipFill>
         <p:spPr>
           <a:xfrm>
-            <a:off x="6199632" y="3494892"/>
-            <a:ext cx="5532120" cy="1697015"/>
+            <a:off x="4276344" y="2542032"/>
+            <a:ext cx="3636264" cy="2911571"/>
           </a:xfrm>
           <a:prstGeom prst="rect">
             <a:avLst/>
@@ -4477,8 +4477,8 @@
         </p:nvSpPr>
         <p:spPr>
           <a:xfrm>
-            <a:off x="6199632" y="5246771"/>
-            <a:ext cx="5532120" cy="292608"/>
+            <a:off x="4276344" y="5998464"/>
+            <a:ext cx="3636264" cy="566928"/>
           </a:xfrm>
           <a:prstGeom prst="rect">
             <a:avLst/>
@@ -4486,7 +4486,7 @@
           <a:noFill/>
         </p:spPr>
         <p:txBody>
-          <a:bodyPr wrap="square" anchor="t" lIns="0" rIns="0" tIns="0" bIns="0">
+          <a:bodyPr wrap="square" anchor="t">
             <a:spAutoFit/>
           </a:bodyPr>
           <a:lstStyle/>
@@ -4500,14 +4500,74 @@
                 <a:latin typeface="맑은 고딕"/>
                 <a:ea typeface="맑은 고딕"/>
               </a:rPr>
-              <a:t>GET /audit - 인증 성공/위조 JWS 거부/폐기 후 인증 실패 실기록</a:t>
-            </a:r>
-          </a:p>
-        </p:txBody>
-      </p:sp>
-      <p:sp>
-        <p:nvSpPr>
-          <p:cNvPr id="11" name="TextBox 10"/>
+              <a:t>Authorization - operator 역할의 admin 전용 API 호출이 403으로 거부</a:t>
+            </a:r>
+          </a:p>
+        </p:txBody>
+      </p:sp>
+      <p:pic>
+        <p:nvPicPr>
+          <p:cNvPr id="11" name="Picture 10" descr="platform_audit.png"/>
+          <p:cNvPicPr>
+            <a:picLocks noChangeAspect="1"/>
+          </p:cNvPicPr>
+          <p:nvPr/>
+        </p:nvPicPr>
+        <p:blipFill>
+          <a:blip r:embed="rId4"/>
+          <a:stretch>
+            <a:fillRect/>
+          </a:stretch>
+        </p:blipFill>
+        <p:spPr>
+          <a:xfrm>
+            <a:off x="8250096" y="2542032"/>
+            <a:ext cx="3327048" cy="3383279"/>
+          </a:xfrm>
+          <a:prstGeom prst="rect">
+            <a:avLst/>
+          </a:prstGeom>
+        </p:spPr>
+      </p:pic>
+      <p:sp>
+        <p:nvSpPr>
+          <p:cNvPr id="12" name="TextBox 11"/>
+          <p:cNvSpPr txBox="1"/>
+          <p:nvPr/>
+        </p:nvSpPr>
+        <p:spPr>
+          <a:xfrm>
+            <a:off x="8095488" y="5998464"/>
+            <a:ext cx="3636264" cy="566928"/>
+          </a:xfrm>
+          <a:prstGeom prst="rect">
+            <a:avLst/>
+          </a:prstGeom>
+          <a:noFill/>
+        </p:spPr>
+        <p:txBody>
+          <a:bodyPr wrap="square" anchor="t">
+            <a:spAutoFit/>
+          </a:bodyPr>
+          <a:lstStyle/>
+          <a:p>
+            <a:pPr algn="ctr"/>
+            <a:r>
+              <a:rPr sz="1050" b="0" i="0">
+                <a:solidFill>
+                  <a:srgbClr val="404040"/>
+                </a:solidFill>
+                <a:latin typeface="맑은 고딕"/>
+                <a:ea typeface="맑은 고딕"/>
+              </a:rPr>
+              <a:t>Accounting - 인증 성공/위조 거부/폐기가 감사로그에 실기록</a:t>
+            </a:r>
+          </a:p>
+        </p:txBody>
+      </p:sp>
+      <p:sp>
+        <p:nvSpPr>
+          <p:cNvPr id="13" name="TextBox 12"/>
           <p:cNvSpPr txBox="1"/>
           <p:nvPr/>
         </p:nvSpPr>
@@ -4542,7 +4602,7 @@
       </p:sp>
       <p:sp>
         <p:nvSpPr>
-          <p:cNvPr id="12" name="TextBox 11"/>
+          <p:cNvPr id="14" name="TextBox 13"/>
           <p:cNvSpPr txBox="1"/>
           <p:nvPr/>
         </p:nvSpPr>
@@ -4680,7 +4740,7 @@
                 <a:latin typeface="맑은 고딕"/>
                 <a:ea typeface="맑은 고딕"/>
               </a:rPr>
-              <a:t>ETRI 2차 킥오프 매핑 자료 기준 - 기존(1차년도) → 현재(2차년도), 캡처는 실제 실행 화면</a:t>
+              <a:t>ETRI 2차 킥오프 매핑 자료 기준 - 기존(1차년도) → 현재(2차년도), 캡처는 실제 플랫폼 화면(Swagger UI·Kubernetes Dashboard·실제 CLI 출력)</a:t>
             </a:r>
           </a:p>
         </p:txBody>
@@ -4907,7 +4967,7 @@
       </p:sp>
       <p:pic>
         <p:nvPicPr>
-          <p:cNvPr id="7" name="Picture 6" descr="screen_k8s_yaml.png"/>
+          <p:cNvPr id="7" name="Picture 6" descr="k8s_dashboard.png"/>
           <p:cNvPicPr>
             <a:picLocks noChangeAspect="1"/>
           </p:cNvPicPr>
@@ -4921,8 +4981,8 @@
         </p:blipFill>
         <p:spPr>
           <a:xfrm>
-            <a:off x="457200" y="2701543"/>
-            <a:ext cx="11274552" cy="3283713"/>
+            <a:off x="457200" y="2542032"/>
+            <a:ext cx="3636264" cy="2424176"/>
           </a:xfrm>
           <a:prstGeom prst="rect">
             <a:avLst/>
@@ -4937,8 +4997,8 @@
         </p:nvSpPr>
         <p:spPr>
           <a:xfrm>
-            <a:off x="457200" y="6040120"/>
-            <a:ext cx="11274552" cy="292608"/>
+            <a:off x="457200" y="5039360"/>
+            <a:ext cx="3636264" cy="566928"/>
           </a:xfrm>
           <a:prstGeom prst="rect">
             <a:avLst/>
@@ -4946,7 +5006,7 @@
           <a:noFill/>
         </p:spPr>
         <p:txBody>
-          <a:bodyPr wrap="square" anchor="t" lIns="0" rIns="0" tIns="0" bIns="0">
+          <a:bodyPr wrap="square" anchor="t">
             <a:spAutoFit/>
           </a:bodyPr>
           <a:lstStyle/>
@@ -4960,14 +5020,134 @@
                 <a:latin typeface="맑은 고딕"/>
                 <a:ea typeface="맑은 고딕"/>
               </a:rPr>
-              <a:t>agent 매니페스트 1차년도(좌) vs 2차년도(우) - 하드코딩 제거, Secret·edge 라벨 적용</a:t>
-            </a:r>
-          </a:p>
-        </p:txBody>
-      </p:sp>
-      <p:sp>
-        <p:nvSpPr>
-          <p:cNvPr id="9" name="TextBox 8"/>
+              <a:t>Kubernetes Dashboard - edge-auth 네임스페이스에 4개 Deployment 구동</a:t>
+            </a:r>
+          </a:p>
+        </p:txBody>
+      </p:sp>
+      <p:pic>
+        <p:nvPicPr>
+          <p:cNvPr id="9" name="Picture 8" descr="k8s_agent_log.png"/>
+          <p:cNvPicPr>
+            <a:picLocks noChangeAspect="1"/>
+          </p:cNvPicPr>
+          <p:nvPr/>
+        </p:nvPicPr>
+        <p:blipFill>
+          <a:blip r:embed="rId3"/>
+          <a:stretch>
+            <a:fillRect/>
+          </a:stretch>
+        </p:blipFill>
+        <p:spPr>
+          <a:xfrm>
+            <a:off x="4276344" y="2542032"/>
+            <a:ext cx="3636264" cy="1212088"/>
+          </a:xfrm>
+          <a:prstGeom prst="rect">
+            <a:avLst/>
+          </a:prstGeom>
+        </p:spPr>
+      </p:pic>
+      <p:sp>
+        <p:nvSpPr>
+          <p:cNvPr id="10" name="TextBox 9"/>
+          <p:cNvSpPr txBox="1"/>
+          <p:nvPr/>
+        </p:nvSpPr>
+        <p:spPr>
+          <a:xfrm>
+            <a:off x="4276344" y="5039360"/>
+            <a:ext cx="3636264" cy="566928"/>
+          </a:xfrm>
+          <a:prstGeom prst="rect">
+            <a:avLst/>
+          </a:prstGeom>
+          <a:noFill/>
+        </p:spPr>
+        <p:txBody>
+          <a:bodyPr wrap="square" anchor="t">
+            <a:spAutoFit/>
+          </a:bodyPr>
+          <a:lstStyle/>
+          <a:p>
+            <a:pPr algn="ctr"/>
+            <a:r>
+              <a:rPr sz="1050" b="0" i="0">
+                <a:solidFill>
+                  <a:srgbClr val="404040"/>
+                </a:solidFill>
+                <a:latin typeface="맑은 고딕"/>
+                <a:ea typeface="맑은 고딕"/>
+              </a:rPr>
+              <a:t>agent 파드 로그 - 실제 등록→토큰→텔레메트리 사이클 성공</a:t>
+            </a:r>
+          </a:p>
+        </p:txBody>
+      </p:sp>
+      <p:pic>
+        <p:nvPicPr>
+          <p:cNvPr id="11" name="Picture 10" descr="screen_k8s_yaml.png"/>
+          <p:cNvPicPr>
+            <a:picLocks noChangeAspect="1"/>
+          </p:cNvPicPr>
+          <p:nvPr/>
+        </p:nvPicPr>
+        <p:blipFill>
+          <a:blip r:embed="rId4"/>
+          <a:stretch>
+            <a:fillRect/>
+          </a:stretch>
+        </p:blipFill>
+        <p:spPr>
+          <a:xfrm>
+            <a:off x="8095488" y="2542032"/>
+            <a:ext cx="3636264" cy="1059061"/>
+          </a:xfrm>
+          <a:prstGeom prst="rect">
+            <a:avLst/>
+          </a:prstGeom>
+        </p:spPr>
+      </p:pic>
+      <p:sp>
+        <p:nvSpPr>
+          <p:cNvPr id="12" name="TextBox 11"/>
+          <p:cNvSpPr txBox="1"/>
+          <p:nvPr/>
+        </p:nvSpPr>
+        <p:spPr>
+          <a:xfrm>
+            <a:off x="8095488" y="5039360"/>
+            <a:ext cx="3636264" cy="566928"/>
+          </a:xfrm>
+          <a:prstGeom prst="rect">
+            <a:avLst/>
+          </a:prstGeom>
+          <a:noFill/>
+        </p:spPr>
+        <p:txBody>
+          <a:bodyPr wrap="square" anchor="t">
+            <a:spAutoFit/>
+          </a:bodyPr>
+          <a:lstStyle/>
+          <a:p>
+            <a:pPr algn="ctr"/>
+            <a:r>
+              <a:rPr sz="1050" b="0" i="0">
+                <a:solidFill>
+                  <a:srgbClr val="404040"/>
+                </a:solidFill>
+                <a:latin typeface="맑은 고딕"/>
+                <a:ea typeface="맑은 고딕"/>
+              </a:rPr>
+              <a:t>매니페스트 1차년도(좌) vs 2차년도(우) - 하드코딩 제거, Secret·edge 라벨</a:t>
+            </a:r>
+          </a:p>
+        </p:txBody>
+      </p:sp>
+      <p:sp>
+        <p:nvSpPr>
+          <p:cNvPr id="13" name="TextBox 12"/>
           <p:cNvSpPr txBox="1"/>
           <p:nvPr/>
         </p:nvSpPr>
@@ -5002,7 +5182,7 @@
       </p:sp>
       <p:sp>
         <p:nvSpPr>
-          <p:cNvPr id="10" name="TextBox 9"/>
+          <p:cNvPr id="14" name="TextBox 13"/>
           <p:cNvSpPr txBox="1"/>
           <p:nvPr/>
         </p:nvSpPr>
@@ -5140,7 +5320,7 @@
                 <a:latin typeface="맑은 고딕"/>
                 <a:ea typeface="맑은 고딕"/>
               </a:rPr>
-              <a:t>ETRI 2차 킥오프 매핑 자료 기준 - 기존(1차년도) → 현재(2차년도), 캡처는 실제 실행 화면</a:t>
+              <a:t>ETRI 2차 킥오프 매핑 자료 기준 - 기존(1차년도) → 현재(2차년도), 캡처는 실제 플랫폼 화면(Swagger UI·Kubernetes Dashboard·실제 CLI 출력)</a:t>
             </a:r>
           </a:p>
         </p:txBody>
@@ -5381,8 +5561,8 @@
         </p:blipFill>
         <p:spPr>
           <a:xfrm>
-            <a:off x="517019" y="2542032"/>
-            <a:ext cx="11154914" cy="3602736"/>
+            <a:off x="457200" y="2640943"/>
+            <a:ext cx="11274552" cy="3404914"/>
           </a:xfrm>
           <a:prstGeom prst="rect">
             <a:avLst/>
@@ -5397,7 +5577,7 @@
         </p:nvSpPr>
         <p:spPr>
           <a:xfrm>
-            <a:off x="457200" y="6199632"/>
+            <a:off x="457200" y="6100721"/>
             <a:ext cx="11274552" cy="292608"/>
           </a:xfrm>
           <a:prstGeom prst="rect">
@@ -5600,7 +5780,7 @@
                 <a:latin typeface="맑은 고딕"/>
                 <a:ea typeface="맑은 고딕"/>
               </a:rPr>
-              <a:t>ETRI 2차 킥오프 매핑 자료 기준 - 기존(1차년도) → 현재(2차년도), 캡처는 실제 실행 화면</a:t>
+              <a:t>ETRI 2차 킥오프 매핑 자료 기준 - 기존(1차년도) → 현재(2차년도), 캡처는 실제 플랫폼 화면(Swagger UI·Kubernetes Dashboard·실제 CLI 출력)</a:t>
             </a:r>
           </a:p>
         </p:txBody>
@@ -5827,7 +6007,7 @@
       </p:sp>
       <p:pic>
         <p:nvPicPr>
-          <p:cNvPr id="7" name="Picture 6" descr="screen_swagger.png"/>
+          <p:cNvPr id="7" name="Picture 6" descr="platform_swagger_overview.png"/>
           <p:cNvPicPr>
             <a:picLocks noChangeAspect="1"/>
           </p:cNvPicPr>
@@ -5841,8 +6021,8 @@
         </p:blipFill>
         <p:spPr>
           <a:xfrm>
-            <a:off x="3428451" y="2542032"/>
-            <a:ext cx="5332049" cy="3602736"/>
+            <a:off x="3392424" y="2542032"/>
+            <a:ext cx="5404104" cy="3602736"/>
           </a:xfrm>
           <a:prstGeom prst="rect">
             <a:avLst/>
@@ -6060,7 +6240,7 @@
                 <a:latin typeface="맑은 고딕"/>
                 <a:ea typeface="맑은 고딕"/>
               </a:rPr>
-              <a:t>ETRI 2차 킥오프 매핑 자료 기준 - 기존(1차년도) → 현재(2차년도), 캡처는 실제 실행 화면</a:t>
+              <a:t>ETRI 2차 킥오프 매핑 자료 기준 - 기존(1차년도) → 현재(2차년도), 캡처는 실제 플랫폼 화면(Swagger UI·Kubernetes Dashboard·실제 CLI 출력)</a:t>
             </a:r>
           </a:p>
         </p:txBody>
@@ -6284,8 +6464,8 @@
         </p:blipFill>
         <p:spPr>
           <a:xfrm>
-            <a:off x="3085419" y="2542032"/>
-            <a:ext cx="6018114" cy="3602736"/>
+            <a:off x="2908094" y="2542032"/>
+            <a:ext cx="6372764" cy="3602735"/>
           </a:xfrm>
           <a:prstGeom prst="rect">
             <a:avLst/>
@@ -6300,7 +6480,7 @@
         </p:nvSpPr>
         <p:spPr>
           <a:xfrm>
-            <a:off x="457200" y="6199632"/>
+            <a:off x="457200" y="6199631"/>
             <a:ext cx="11274552" cy="292608"/>
           </a:xfrm>
           <a:prstGeom prst="rect">

</xml_diff>